<commit_message>
Abb. 2.1: Phase „Analyse und Kontrolle“
Linkes Segment des Management-Regelkreises heißt jetzt „Analyse und
Kontrolle“ statt „Kontrollieren, Vergleichen, Analysieren, Berichten“
(Vorgabe Autor). PNG, PDF, PPTX, Vorschau, Alternativtext und
Inventur aktualisiert.

Co-Authored-By: Claude Opus 5.5 <noreply@anthropic.com>
Claude-Session: https://claude.ai/code/session_015a49Vr6vK6JHdw6trSezHk
</commit_message>
<xml_diff>
--- a/abbildungen/kap2/abb_2-1.pptx
+++ b/abbildungen/kap2/abb_2-1.pptx
@@ -4118,7 +4118,7 @@
       </p:sp>
       <p:sp>
         <p:nvSpPr>
-          <p:cNvPr id="6" name="Segment Kontrollieren"/>
+          <p:cNvPr id="6" name="Segment Analyse"/>
           <p:cNvSpPr/>
           <p:nvPr/>
         </p:nvSpPr>
@@ -4607,14 +4607,14 @@
       </p:sp>
       <p:sp>
         <p:nvSpPr>
-          <p:cNvPr id="11" name="Text Kontrollieren"/>
+          <p:cNvPr id="11" name="Text Analyse"/>
           <p:cNvSpPr txBox="1"/>
           <p:nvPr/>
         </p:nvSpPr>
         <p:spPr>
           <a:xfrm>
-            <a:off x="811980" y="1096343"/>
-            <a:ext cx="603596" cy="448408"/>
+            <a:off x="893501" y="1148794"/>
+            <a:ext cx="440554" cy="343506"/>
           </a:xfrm>
           <a:prstGeom prst="rect">
             <a:avLst/>
@@ -4640,7 +4640,7 @@
                 </a:solidFill>
                 <a:latin typeface="Arial"/>
               </a:rPr>
-              <a:t>Kontrollieren</a:t>
+              <a:t>Analyse</a:t>
             </a:r>
             <a:br>
               <a:rPr lang="de-DE" sz="700" b="1" i="0">
@@ -4658,7 +4658,7 @@
                 </a:solidFill>
                 <a:latin typeface="Arial"/>
               </a:rPr>
-              <a:t>Vergleichen</a:t>
+              <a:t>und</a:t>
             </a:r>
             <a:br>
               <a:rPr lang="de-DE" sz="700" b="1" i="0">
@@ -4676,25 +4676,7 @@
                 </a:solidFill>
                 <a:latin typeface="Arial"/>
               </a:rPr>
-              <a:t>Analysieren</a:t>
-            </a:r>
-            <a:br>
-              <a:rPr lang="de-DE" sz="700" b="1" i="0">
-                <a:solidFill>
-                  <a:srgbClr val="1A1A1A"/>
-                </a:solidFill>
-                <a:latin typeface="Arial"/>
-                <a:cs typeface="Arial"/>
-              </a:rPr>
-            </a:br>
-            <a:r>
-              <a:rPr lang="de-DE" sz="700" b="1" i="0">
-                <a:solidFill>
-                  <a:srgbClr val="1A1A1A"/>
-                </a:solidFill>
-                <a:latin typeface="Arial"/>
-              </a:rPr>
-              <a:t>Berichten</a:t>
+              <a:t>Kontrolle</a:t>
             </a:r>
           </a:p>
         </p:txBody>

</xml_diff>